<commit_message>
Release v1.0-finals: Sarvam-primary router, prewarmed cache seeding, Task A-H fixes & 12/12 preflight
</commit_message>
<xml_diff>
--- a/deck/v3/PaytmAI_VyaparVoice_v3.pptx
+++ b/deck/v3/PaytmAI_VyaparVoice_v3.pptx
@@ -20685,7 +20685,7 @@
                 </a:solidFill>
                 <a:latin typeface="Liberation Sans"/>
               </a:rPr>
-              <a:t>Privacy-Safe Service Recovery</a:t>
+              <a:t>Privacy-Safe Regular Retention</a:t>
             </a:r>
           </a:p>
         </p:txBody>
@@ -20725,7 +20725,7 @@
                 </a:solidFill>
                 <a:latin typeface="Liberation Sans"/>
               </a:rPr>
-              <a:t>Delay Tagging (Simulated): </a:t>
+              <a:t>Ledger Gap Detection (Built): </a:t>
             </a:r>
             <a:r>
               <a:rPr sz="1200" b="0">
@@ -20734,7 +20734,7 @@
                 </a:solidFill>
                 <a:latin typeface="Liberation Sans"/>
               </a:rPr>
-              <a:t>Flags peak-hour queue delays and 3-star feedback tags.</a:t>
+              <a:t>Spots 12+ visit regulars (~2d gap) silent 8+ days after dense rush scans.</a:t>
             </a:r>
           </a:p>
           <a:p>
@@ -20760,7 +20760,7 @@
                 </a:solidFill>
                 <a:latin typeface="Liberation Sans"/>
               </a:rPr>
-              <a:t>1-tap bilingual apology + Rs 30 next-scan coffee voucher.</a:t>
+              <a:t>1-tap polite welcome-back note + Rs 30 next-scan coffee voucher.</a:t>
             </a:r>
           </a:p>
           <a:p>

</xml_diff>